<commit_message>
Update tennis shoe value chain presentation
</commit_message>
<xml_diff>
--- a/08_tennis_shoe_value_chain_analysis/tennis_shoe_value_chain_analysis.pptx
+++ b/08_tennis_shoe_value_chain_analysis/tennis_shoe_value_chain_analysis.pptx
@@ -268,7 +268,7 @@
           <a:p>
             <a:fld id="{52413606-CBC0-C145-B591-62BE129C27CC}" type="datetimeFigureOut">
               <a:rPr lang="en-US" smtClean="0"/>
-              <a:t>2/6/25</a:t>
+              <a:t>9/23/26</a:t>
             </a:fld>
             <a:endParaRPr lang="en-US"/>
           </a:p>
@@ -468,7 +468,7 @@
           <a:p>
             <a:fld id="{52413606-CBC0-C145-B591-62BE129C27CC}" type="datetimeFigureOut">
               <a:rPr lang="en-US" smtClean="0"/>
-              <a:t>2/6/25</a:t>
+              <a:t>9/23/26</a:t>
             </a:fld>
             <a:endParaRPr lang="en-US"/>
           </a:p>
@@ -678,7 +678,7 @@
           <a:p>
             <a:fld id="{52413606-CBC0-C145-B591-62BE129C27CC}" type="datetimeFigureOut">
               <a:rPr lang="en-US" smtClean="0"/>
-              <a:t>2/6/25</a:t>
+              <a:t>9/23/26</a:t>
             </a:fld>
             <a:endParaRPr lang="en-US"/>
           </a:p>
@@ -878,7 +878,7 @@
           <a:p>
             <a:fld id="{52413606-CBC0-C145-B591-62BE129C27CC}" type="datetimeFigureOut">
               <a:rPr lang="en-US" smtClean="0"/>
-              <a:t>2/6/25</a:t>
+              <a:t>9/23/26</a:t>
             </a:fld>
             <a:endParaRPr lang="en-US"/>
           </a:p>
@@ -1154,7 +1154,7 @@
           <a:p>
             <a:fld id="{52413606-CBC0-C145-B591-62BE129C27CC}" type="datetimeFigureOut">
               <a:rPr lang="en-US" smtClean="0"/>
-              <a:t>2/6/25</a:t>
+              <a:t>9/23/26</a:t>
             </a:fld>
             <a:endParaRPr lang="en-US"/>
           </a:p>
@@ -1422,7 +1422,7 @@
           <a:p>
             <a:fld id="{52413606-CBC0-C145-B591-62BE129C27CC}" type="datetimeFigureOut">
               <a:rPr lang="en-US" smtClean="0"/>
-              <a:t>2/6/25</a:t>
+              <a:t>9/23/26</a:t>
             </a:fld>
             <a:endParaRPr lang="en-US"/>
           </a:p>
@@ -1837,7 +1837,7 @@
           <a:p>
             <a:fld id="{52413606-CBC0-C145-B591-62BE129C27CC}" type="datetimeFigureOut">
               <a:rPr lang="en-US" smtClean="0"/>
-              <a:t>2/6/25</a:t>
+              <a:t>9/23/26</a:t>
             </a:fld>
             <a:endParaRPr lang="en-US"/>
           </a:p>
@@ -1979,7 +1979,7 @@
           <a:p>
             <a:fld id="{52413606-CBC0-C145-B591-62BE129C27CC}" type="datetimeFigureOut">
               <a:rPr lang="en-US" smtClean="0"/>
-              <a:t>2/6/25</a:t>
+              <a:t>9/23/26</a:t>
             </a:fld>
             <a:endParaRPr lang="en-US"/>
           </a:p>
@@ -2092,7 +2092,7 @@
           <a:p>
             <a:fld id="{52413606-CBC0-C145-B591-62BE129C27CC}" type="datetimeFigureOut">
               <a:rPr lang="en-US" smtClean="0"/>
-              <a:t>2/6/25</a:t>
+              <a:t>9/23/26</a:t>
             </a:fld>
             <a:endParaRPr lang="en-US"/>
           </a:p>
@@ -2405,7 +2405,7 @@
           <a:p>
             <a:fld id="{52413606-CBC0-C145-B591-62BE129C27CC}" type="datetimeFigureOut">
               <a:rPr lang="en-US" smtClean="0"/>
-              <a:t>2/6/25</a:t>
+              <a:t>9/23/26</a:t>
             </a:fld>
             <a:endParaRPr lang="en-US"/>
           </a:p>
@@ -2694,7 +2694,7 @@
           <a:p>
             <a:fld id="{52413606-CBC0-C145-B591-62BE129C27CC}" type="datetimeFigureOut">
               <a:rPr lang="en-US" smtClean="0"/>
-              <a:t>2/6/25</a:t>
+              <a:t>9/23/26</a:t>
             </a:fld>
             <a:endParaRPr lang="en-US"/>
           </a:p>
@@ -2937,7 +2937,7 @@
           <a:p>
             <a:fld id="{52413606-CBC0-C145-B591-62BE129C27CC}" type="datetimeFigureOut">
               <a:rPr lang="en-US" smtClean="0"/>
-              <a:t>2/6/25</a:t>
+              <a:t>9/23/26</a:t>
             </a:fld>
             <a:endParaRPr lang="en-US"/>
           </a:p>
@@ -4914,23 +4914,6 @@
                 <a:latin typeface="Arial" panose="020B0604020202020204" pitchFamily="34" charset="0"/>
                 <a:cs typeface="Arial" panose="020B0604020202020204" pitchFamily="34" charset="0"/>
               </a:rPr>
-              <a:t>List out 2-3 bullet points about their interactions</a:t>
-            </a:r>
-          </a:p>
-          <a:p>
-            <a:pPr algn="ctr"/>
-            <a:endParaRPr lang="en-US" sz="1200" i="1" dirty="0">
-              <a:latin typeface="Arial" panose="020B0604020202020204" pitchFamily="34" charset="0"/>
-              <a:cs typeface="Arial" panose="020B0604020202020204" pitchFamily="34" charset="0"/>
-            </a:endParaRPr>
-          </a:p>
-          <a:p>
-            <a:pPr algn="ctr"/>
-            <a:r>
-              <a:rPr lang="en-US" sz="1200" i="1" dirty="0">
-                <a:latin typeface="Arial" panose="020B0604020202020204" pitchFamily="34" charset="0"/>
-                <a:cs typeface="Arial" panose="020B0604020202020204" pitchFamily="34" charset="0"/>
-              </a:rPr>
               <a:t>Suppliers provide key materials like rubber, synthetic fibers, and cushioning technologies, and each company is trying to secure access to the most innovative materials and technologies at the best prices.</a:t>
             </a:r>
           </a:p>
@@ -5200,48 +5183,6 @@
               <a:latin typeface="Arial" panose="020B0604020202020204" pitchFamily="34" charset="0"/>
               <a:cs typeface="Arial" panose="020B0604020202020204" pitchFamily="34" charset="0"/>
             </a:endParaRPr>
-          </a:p>
-          <a:p>
-            <a:pPr algn="ctr"/>
-            <a:endParaRPr lang="en-US" sz="1200" i="1" dirty="0">
-              <a:latin typeface="Arial" panose="020B0604020202020204" pitchFamily="34" charset="0"/>
-              <a:cs typeface="Arial" panose="020B0604020202020204" pitchFamily="34" charset="0"/>
-            </a:endParaRPr>
-          </a:p>
-          <a:p>
-            <a:pPr algn="ctr"/>
-            <a:endParaRPr lang="en-US" sz="1200" i="1" dirty="0">
-              <a:latin typeface="Arial" panose="020B0604020202020204" pitchFamily="34" charset="0"/>
-              <a:cs typeface="Arial" panose="020B0604020202020204" pitchFamily="34" charset="0"/>
-            </a:endParaRPr>
-          </a:p>
-          <a:p>
-            <a:pPr algn="ctr"/>
-            <a:r>
-              <a:rPr lang="en-US" sz="1200" i="1" dirty="0">
-                <a:latin typeface="Arial" panose="020B0604020202020204" pitchFamily="34" charset="0"/>
-                <a:cs typeface="Arial" panose="020B0604020202020204" pitchFamily="34" charset="0"/>
-              </a:rPr>
-              <a:t>List out 2-3 bullet points about </a:t>
-            </a:r>
-            <a:r>
-              <a:rPr lang="en-GB" sz="1200" i="1" dirty="0">
-                <a:effectLst/>
-                <a:highlight>
-                  <a:srgbClr val="FFFFFF"/>
-                </a:highlight>
-                <a:latin typeface="Arial" panose="020B0604020202020204" pitchFamily="34" charset="0"/>
-                <a:cs typeface="Arial" panose="020B0604020202020204" pitchFamily="34" charset="0"/>
-              </a:rPr>
-              <a:t>Regulatory + Environmental Factors</a:t>
-            </a:r>
-            <a:r>
-              <a:rPr lang="en-US" sz="1200" i="1" dirty="0">
-                <a:latin typeface="Arial" panose="020B0604020202020204" pitchFamily="34" charset="0"/>
-                <a:cs typeface="Arial" panose="020B0604020202020204" pitchFamily="34" charset="0"/>
-              </a:rPr>
-              <a:t> in the tennis shoe industry</a:t>
-            </a:r>
           </a:p>
           <a:p>
             <a:pPr algn="ctr"/>
@@ -6141,30 +6082,6 @@
               <a:latin typeface="Arial" panose="020B0604020202020204" pitchFamily="34" charset="0"/>
               <a:cs typeface="Arial" panose="020B0604020202020204" pitchFamily="34" charset="0"/>
             </a:endParaRPr>
-          </a:p>
-          <a:p>
-            <a:pPr algn="ctr"/>
-            <a:endParaRPr lang="en-US" sz="1200" i="1" dirty="0">
-              <a:latin typeface="Arial" panose="020B0604020202020204" pitchFamily="34" charset="0"/>
-              <a:cs typeface="Arial" panose="020B0604020202020204" pitchFamily="34" charset="0"/>
-            </a:endParaRPr>
-          </a:p>
-          <a:p>
-            <a:pPr algn="ctr"/>
-            <a:endParaRPr lang="en-US" sz="1200" i="1" dirty="0">
-              <a:latin typeface="Arial" panose="020B0604020202020204" pitchFamily="34" charset="0"/>
-              <a:cs typeface="Arial" panose="020B0604020202020204" pitchFamily="34" charset="0"/>
-            </a:endParaRPr>
-          </a:p>
-          <a:p>
-            <a:pPr algn="ctr"/>
-            <a:r>
-              <a:rPr lang="en-US" sz="1200" i="1" dirty="0">
-                <a:latin typeface="Arial" panose="020B0604020202020204" pitchFamily="34" charset="0"/>
-                <a:cs typeface="Arial" panose="020B0604020202020204" pitchFamily="34" charset="0"/>
-              </a:rPr>
-              <a:t>List out 2-3 bullet points about trends in the tennis shoe industry</a:t>
-            </a:r>
           </a:p>
           <a:p>
             <a:pPr algn="ctr"/>

</xml_diff>